<commit_message>
Add PDF delivery for repository summary decks
</commit_message>
<xml_diff>
--- a/repo-daily-summary/assets/repo-daily-summary-template.pptx
+++ b/repo-daily-summary/assets/repo-daily-summary-template.pptx
@@ -7059,17 +7059,45 @@
           <a:lstStyle/>
           <a:p>
             <a:pPr marL="0" indent="0">
+              <a:buNone/>
               <a:lnSpc>
                 <a:spcPct val="114000"/>
               </a:lnSpc>
-              <a:buFont typeface="Arial" panose="020B0604020202020204" pitchFamily="34" charset="0"/>
+            </a:pPr>
+            <a:r>
+              <a:rPr sz="2400" b="1">
+                <a:latin typeface="Arial"/>
+              </a:rPr>
+              <a:t>+ Priority 1 (major progress)</a:t>
+            </a:r>
+          </a:p>
+          <a:p>
+            <a:pPr lvl="1"/>
+            <a:r>
+              <a:rPr sz="2200" b="0">
+                <a:latin typeface="Arial"/>
+              </a:rPr>
+              <a:t>[Repository / workstream] - [validated milestone or capability]</a:t>
+            </a:r>
+          </a:p>
+          <a:p>
+            <a:pPr lvl="1"/>
+            <a:r>
+              <a:rPr sz="2200" b="0">
+                <a:latin typeface="Arial"/>
+              </a:rPr>
+              <a:t>[Repository / workstream] - [validated milestone or capability]</a:t>
+            </a:r>
+          </a:p>
+          <a:p>
+            <a:pPr>
               <a:buNone/>
             </a:pPr>
             <a:r>
               <a:rPr sz="2400" b="1">
                 <a:latin typeface="Arial"/>
               </a:rPr>
-              <a:t>+ Priority 1 (major progress)</a:t>
+              <a:t>+ Priority 2 (supporting progress)</a:t>
             </a:r>
           </a:p>
           <a:p>
@@ -7078,38 +7106,13 @@
               <a:rPr sz="2200" b="0">
                 <a:latin typeface="Arial"/>
               </a:rPr>
-              <a:t>[Repository / workstream] - [validated milestone or capability]</a:t>
-            </a:r>
-          </a:p>
-          <a:p>
-            <a:pPr lvl="1"/>
-            <a:r>
-              <a:rPr sz="2200" b="0">
-                <a:latin typeface="Arial"/>
-              </a:rPr>
-              <a:t>[Repository / workstream] - [validated milestone or capability]</a:t>
-            </a:r>
-          </a:p>
-          <a:p>
-            <a:pPr/>
-            <a:r>
-              <a:rPr sz="2400" b="1">
-                <a:latin typeface="Arial"/>
-              </a:rPr>
-              <a:t>+ Priority 2 (supporting progress)</a:t>
-            </a:r>
-          </a:p>
-          <a:p>
-            <a:pPr lvl="1"/>
-            <a:r>
-              <a:rPr sz="2200" b="0">
-                <a:latin typeface="Arial"/>
-              </a:rPr>
               <a:t>[Supporting result, integration, or evaluation progress]</a:t>
             </a:r>
           </a:p>
           <a:p>
-            <a:pPr/>
+            <a:pPr>
+              <a:buNone/>
+            </a:pPr>
             <a:r>
               <a:rPr sz="2400" b="1">
                 <a:latin typeface="Arial"/>
@@ -7353,16 +7356,25 @@
           <a:bodyPr/>
           <a:lstStyle/>
           <a:p>
+            <a:pPr>
+              <a:buNone/>
+            </a:pPr>
             <a:r>
               <a:t>[Name]</a:t>
             </a:r>
           </a:p>
           <a:p>
+            <a:pPr>
+              <a:buNone/>
+            </a:pPr>
             <a:r>
               <a:t>[Department]</a:t>
             </a:r>
           </a:p>
           <a:p>
+            <a:pPr>
+              <a:buNone/>
+            </a:pPr>
             <a:r>
               <a:t>[Institution]</a:t>
             </a:r>
@@ -7580,9 +7592,11 @@
           <a:bodyPr wrap="square"/>
           <a:lstStyle/>
           <a:p>
-            <a:pPr algn="just"/>
-            <a:r>
-              <a:rPr sz="2400" b="1">
+            <a:pPr algn="just">
+              <a:buNone/>
+            </a:pPr>
+            <a:r>
+              <a:rPr sz="2200" b="1">
                 <a:latin typeface="Arial"/>
               </a:rPr>
               <a:t>Objective</a:t>
@@ -7591,16 +7605,18 @@
           <a:p>
             <a:pPr lvl="1"/>
             <a:r>
-              <a:rPr sz="1900" b="0">
+              <a:rPr sz="1800" b="0">
                 <a:latin typeface="Arial"/>
               </a:rPr>
               <a:t>[One sentence describing the research or product objective]</a:t>
             </a:r>
           </a:p>
           <a:p>
-            <a:pPr/>
-            <a:r>
-              <a:rPr sz="2400" b="1">
+            <a:pPr>
+              <a:buNone/>
+            </a:pPr>
+            <a:r>
+              <a:rPr sz="2200" b="1">
                 <a:latin typeface="Arial"/>
               </a:rPr>
               <a:t>Implemented</a:t>
@@ -7609,7 +7625,7 @@
           <a:p>
             <a:pPr lvl="1"/>
             <a:r>
-              <a:rPr sz="1900" b="0">
+              <a:rPr sz="1800" b="0">
                 <a:latin typeface="Arial"/>
               </a:rPr>
               <a:t>[Technical capability and key method, e.g. YOLO, OCR, SPICE]</a:t>
@@ -7618,7 +7634,7 @@
           <a:p>
             <a:pPr lvl="1"/>
             <a:r>
-              <a:rPr sz="1900" b="0">
+              <a:rPr sz="1800" b="0">
                 <a:latin typeface="Arial"/>
               </a:rPr>
               <a:t>[Second durable capability]</a:t>
@@ -7627,16 +7643,18 @@
           <a:p>
             <a:pPr lvl="1"/>
             <a:r>
-              <a:rPr sz="1900" b="0">
+              <a:rPr sz="1800" b="0">
                 <a:latin typeface="Arial"/>
               </a:rPr>
               <a:t>[Third durable capability]</a:t>
             </a:r>
           </a:p>
           <a:p>
-            <a:pPr/>
-            <a:r>
-              <a:rPr sz="2400" b="1">
+            <a:pPr>
+              <a:buNone/>
+            </a:pPr>
+            <a:r>
+              <a:rPr sz="2200" b="1">
                 <a:latin typeface="Arial"/>
               </a:rPr>
               <a:t>Results</a:t>
@@ -7645,7 +7663,7 @@
           <a:p>
             <a:pPr lvl="1"/>
             <a:r>
-              <a:rPr sz="1900" b="0">
+              <a:rPr sz="1800" b="0">
                 <a:latin typeface="Arial"/>
               </a:rPr>
               <a:t>[Verified outcome with scale or quantitative evidence]</a:t>
@@ -7654,16 +7672,18 @@
           <a:p>
             <a:pPr lvl="1"/>
             <a:r>
-              <a:rPr sz="1900" b="0">
+              <a:rPr sz="1800" b="0">
                 <a:latin typeface="Arial"/>
               </a:rPr>
               <a:t>[Second verified outcome or remaining limitation]</a:t>
             </a:r>
           </a:p>
           <a:p>
-            <a:pPr/>
-            <a:r>
-              <a:rPr sz="2400" b="1">
+            <a:pPr>
+              <a:buNone/>
+            </a:pPr>
+            <a:r>
+              <a:rPr sz="2200" b="1">
                 <a:latin typeface="Arial"/>
               </a:rPr>
               <a:t>Next</a:t>
@@ -7672,7 +7692,7 @@
           <a:p>
             <a:pPr lvl="1"/>
             <a:r>
-              <a:rPr sz="1900" b="0">
+              <a:rPr sz="1800" b="0">
                 <a:latin typeface="Arial"/>
               </a:rPr>
               <a:t>[Next meaningful validation or research milestone]</a:t>
@@ -7681,7 +7701,7 @@
           <a:p>
             <a:pPr lvl="1"/>
             <a:r>
-              <a:rPr sz="1900" b="0">
+              <a:rPr sz="1800" b="0">
                 <a:latin typeface="Arial"/>
               </a:rPr>
               <a:t>[Follow-on integration or generalization target]</a:t>

</xml_diff>